<commit_message>
Repair 023 profile driven renderer
</commit_message>
<xml_diff>
--- a/results/023_research_presentation_deck_design_system_integration/generated/medical_design_system_fixture/medical_design_system_fixture.pptx
+++ b/results/023_research_presentation_deck_design_system_integration/generated/medical_design_system_fixture/medical_design_system_fixture.pptx
@@ -3437,7 +3437,7 @@
           <a:lstStyle/>
           <a:p>
             <a:r>
-              <a:rPr sz="900" b="0">
+              <a:rPr sz="1000" b="0">
                 <a:solidFill>
                   <a:srgbClr val="586274"/>
                 </a:solidFill>
@@ -3516,7 +3516,7 @@
           <a:lstStyle/>
           <a:p>
             <a:r>
-              <a:rPr sz="900" b="0">
+              <a:rPr sz="1000" b="0">
                 <a:solidFill>
                   <a:srgbClr val="586274"/>
                 </a:solidFill>
@@ -3595,7 +3595,7 @@
           <a:lstStyle/>
           <a:p>
             <a:r>
-              <a:rPr sz="900" b="0">
+              <a:rPr sz="1000" b="0">
                 <a:solidFill>
                   <a:srgbClr val="586274"/>
                 </a:solidFill>
@@ -3804,7 +3804,7 @@
           <a:p>
             <a:pPr algn="ctr"/>
             <a:r>
-              <a:rPr sz="1400" b="1">
+              <a:rPr sz="1500" b="1">
                 <a:solidFill>
                   <a:srgbClr val="171C26"/>
                 </a:solidFill>
@@ -3919,7 +3919,7 @@
           <a:p>
             <a:pPr algn="ctr"/>
             <a:r>
-              <a:rPr sz="1400" b="1">
+              <a:rPr sz="1500" b="1">
                 <a:solidFill>
                   <a:srgbClr val="171C26"/>
                 </a:solidFill>
@@ -4034,7 +4034,7 @@
           <a:p>
             <a:pPr algn="ctr"/>
             <a:r>
-              <a:rPr sz="1400" b="1">
+              <a:rPr sz="1500" b="1">
                 <a:solidFill>
                   <a:srgbClr val="171C26"/>
                 </a:solidFill>
@@ -4149,7 +4149,7 @@
           <a:p>
             <a:pPr algn="ctr"/>
             <a:r>
-              <a:rPr sz="1400" b="1">
+              <a:rPr sz="1500" b="1">
                 <a:solidFill>
                   <a:srgbClr val="171C26"/>
                 </a:solidFill>
@@ -4846,7 +4846,7 @@
           <a:lstStyle/>
           <a:p>
             <a:r>
-              <a:rPr sz="900" b="0">
+              <a:rPr sz="1000" b="0">
                 <a:solidFill>
                   <a:srgbClr val="586274"/>
                 </a:solidFill>
@@ -4925,7 +4925,7 @@
           <a:lstStyle/>
           <a:p>
             <a:r>
-              <a:rPr sz="900" b="0">
+              <a:rPr sz="1000" b="0">
                 <a:solidFill>
                   <a:srgbClr val="586274"/>
                 </a:solidFill>
@@ -5004,7 +5004,7 @@
           <a:lstStyle/>
           <a:p>
             <a:r>
-              <a:rPr sz="900" b="0">
+              <a:rPr sz="1000" b="0">
                 <a:solidFill>
                   <a:srgbClr val="586274"/>
                 </a:solidFill>

</xml_diff>